<commit_message>
Add CEGIS-dual elegance section across all deliverables
PDF report: new Section 1.2 "The Elegance of the Duality" with
structural inversion analysis, convergence inheritance, and
gap-taxonomy-as-counterexample-traces framing.
PPTX: enriched insight slide with precise duality description.
README: elegance paragraph in Theoretical Contribution section.

Co-Authored-By: Claude Opus 4.6 <noreply@anthropic.com>
</commit_message>
<xml_diff>
--- a/submission/SpecSaboteur_Presentation.pptx
+++ b/submission/SpecSaboteur_Presentation.pptx
@@ -4788,8 +4788,8 @@
         </p:nvSpPr>
         <p:spPr>
           <a:xfrm>
-            <a:off x="731520" y="5029200"/>
-            <a:ext cx="10515600" cy="914400"/>
+            <a:off x="731520" y="4754880"/>
+            <a:ext cx="10515600" cy="1371600"/>
           </a:xfrm>
           <a:prstGeom prst="rect">
             <a:avLst/>
@@ -4803,7 +4803,7 @@
           <a:lstStyle/>
           <a:p>
             <a:pPr algn="ctr">
-              <a:defRPr sz="1600" b="0">
+              <a:defRPr sz="1400" b="0">
                 <a:solidFill>
                   <a:srgbClr val="D2A8FF"/>
                 </a:solidFill>
@@ -4811,7 +4811,15 @@
               </a:defRPr>
             </a:pPr>
             <a:r>
-              <a:t>First tool that generates adversarial implementations verified against formal specs to find semantic gaps.</a:t>
+              <a:t>Same verifier. Same convergence structure. Same termination condition.</a:t>
+            </a:r>
+            <a:br/>
+            <a:r>
+              <a:t>The objects swap: spec is fixed in CEGIS, impl is the probe in CEGIS-Dual.</a:t>
+            </a:r>
+            <a:br/>
+            <a:r>
+              <a:t>Gap taxonomy = spec-domain analogue of counterexample traces.</a:t>
             </a:r>
           </a:p>
         </p:txBody>

</xml_diff>